<commit_message>
Update scirpt - Program.cs
</commit_message>
<xml_diff>
--- a/1.training_model/supplementary/Device Identifier 20260520.pptx
+++ b/1.training_model/supplementary/Device Identifier 20260520.pptx
@@ -5,7 +5,7 @@
     <p:sldMasterId id="2147483696" r:id="rId1"/>
   </p:sldMasterIdLst>
   <p:notesMasterIdLst>
-    <p:notesMasterId r:id="rId11"/>
+    <p:notesMasterId r:id="rId12"/>
   </p:notesMasterIdLst>
   <p:sldIdLst>
     <p:sldId id="256" r:id="rId2"/>
@@ -14,9 +14,10 @@
     <p:sldId id="328" r:id="rId5"/>
     <p:sldId id="329" r:id="rId6"/>
     <p:sldId id="330" r:id="rId7"/>
-    <p:sldId id="323" r:id="rId8"/>
-    <p:sldId id="327" r:id="rId9"/>
-    <p:sldId id="326" r:id="rId10"/>
+    <p:sldId id="331" r:id="rId8"/>
+    <p:sldId id="323" r:id="rId9"/>
+    <p:sldId id="327" r:id="rId10"/>
+    <p:sldId id="326" r:id="rId11"/>
   </p:sldIdLst>
   <p:sldSz cx="12192000" cy="6858000"/>
   <p:notesSz cx="6858000" cy="9144000"/>
@@ -205,7 +206,7 @@
           <a:p>
             <a:fld id="{23D8B80A-F233-4240-BDAF-6537AE249829}" type="datetimeFigureOut">
               <a:rPr lang="en-MY" smtClean="0"/>
-              <a:t>15/6/2026</a:t>
+              <a:t>18/6/2026</a:t>
             </a:fld>
             <a:endParaRPr lang="en-MY"/>
           </a:p>
@@ -973,6 +974,114 @@
         <p:cNvPr id="1" name="">
           <a:extLst>
             <a:ext uri="{FF2B5EF4-FFF2-40B4-BE49-F238E27FC236}">
+              <a16:creationId xmlns:a16="http://schemas.microsoft.com/office/drawing/2014/main" id="{27AC51A4-DF0B-FDE9-7E77-505DF0963615}"/>
+            </a:ext>
+          </a:extLst>
+        </p:cNvPr>
+        <p:cNvGrpSpPr/>
+        <p:nvPr/>
+      </p:nvGrpSpPr>
+      <p:grpSpPr>
+        <a:xfrm>
+          <a:off x="0" y="0"/>
+          <a:ext cx="0" cy="0"/>
+          <a:chOff x="0" y="0"/>
+          <a:chExt cx="0" cy="0"/>
+        </a:xfrm>
+      </p:grpSpPr>
+      <p:sp>
+        <p:nvSpPr>
+          <p:cNvPr id="2" name="Slide Image Placeholder 1">
+            <a:extLst>
+              <a:ext uri="{FF2B5EF4-FFF2-40B4-BE49-F238E27FC236}">
+                <a16:creationId xmlns:a16="http://schemas.microsoft.com/office/drawing/2014/main" id="{689F12C7-7B82-5718-D799-1E0BDF7D0DC6}"/>
+              </a:ext>
+            </a:extLst>
+          </p:cNvPr>
+          <p:cNvSpPr>
+            <a:spLocks noGrp="1" noRot="1" noChangeAspect="1"/>
+          </p:cNvSpPr>
+          <p:nvPr>
+            <p:ph type="sldImg"/>
+          </p:nvPr>
+        </p:nvSpPr>
+        <p:spPr/>
+      </p:sp>
+      <p:sp>
+        <p:nvSpPr>
+          <p:cNvPr id="3" name="Notes Placeholder 2">
+            <a:extLst>
+              <a:ext uri="{FF2B5EF4-FFF2-40B4-BE49-F238E27FC236}">
+                <a16:creationId xmlns:a16="http://schemas.microsoft.com/office/drawing/2014/main" id="{51C14063-9072-7B10-13CD-D17185884897}"/>
+              </a:ext>
+            </a:extLst>
+          </p:cNvPr>
+          <p:cNvSpPr>
+            <a:spLocks noGrp="1"/>
+          </p:cNvSpPr>
+          <p:nvPr>
+            <p:ph type="body" idx="1"/>
+          </p:nvPr>
+        </p:nvSpPr>
+        <p:spPr/>
+        <p:txBody>
+          <a:bodyPr/>
+          <a:lstStyle/>
+          <a:p>
+            <a:endParaRPr lang="en-MY" dirty="0"/>
+          </a:p>
+        </p:txBody>
+      </p:sp>
+      <p:sp>
+        <p:nvSpPr>
+          <p:cNvPr id="4" name="Slide Number Placeholder 3">
+            <a:extLst>
+              <a:ext uri="{FF2B5EF4-FFF2-40B4-BE49-F238E27FC236}">
+                <a16:creationId xmlns:a16="http://schemas.microsoft.com/office/drawing/2014/main" id="{A9C3D2FF-9922-1F5C-63D9-3AD351D33DD4}"/>
+              </a:ext>
+            </a:extLst>
+          </p:cNvPr>
+          <p:cNvSpPr>
+            <a:spLocks noGrp="1"/>
+          </p:cNvSpPr>
+          <p:nvPr>
+            <p:ph type="sldNum" sz="quarter" idx="5"/>
+          </p:nvPr>
+        </p:nvSpPr>
+        <p:spPr/>
+        <p:txBody>
+          <a:bodyPr/>
+          <a:lstStyle/>
+          <a:p>
+            <a:fld id="{D16833E0-5E66-4D1D-89F5-BD860FDD8F71}" type="slidenum">
+              <a:rPr lang="en-MY" smtClean="0"/>
+              <a:t>7</a:t>
+            </a:fld>
+            <a:endParaRPr lang="en-MY"/>
+          </a:p>
+        </p:txBody>
+      </p:sp>
+    </p:spTree>
+    <p:extLst>
+      <p:ext uri="{BB962C8B-B14F-4D97-AF65-F5344CB8AC3E}">
+        <p14:creationId xmlns:p14="http://schemas.microsoft.com/office/powerpoint/2010/main" val="479054430"/>
+      </p:ext>
+    </p:extLst>
+  </p:cSld>
+  <p:clrMapOvr>
+    <a:masterClrMapping/>
+  </p:clrMapOvr>
+</p:notes>
+</file>
+
+<file path=ppt/notesSlides/notesSlide7.xml><?xml version="1.0" encoding="utf-8"?>
+<p:notes xmlns:a="http://schemas.openxmlformats.org/drawingml/2006/main" xmlns:r="http://schemas.openxmlformats.org/officeDocument/2006/relationships" xmlns:p="http://schemas.openxmlformats.org/presentationml/2006/main">
+  <p:cSld>
+    <p:spTree>
+      <p:nvGrpSpPr>
+        <p:cNvPr id="1" name="">
+          <a:extLst>
+            <a:ext uri="{FF2B5EF4-FFF2-40B4-BE49-F238E27FC236}">
               <a16:creationId xmlns:a16="http://schemas.microsoft.com/office/drawing/2014/main" id="{A183267B-B82B-1EDC-363F-2C9961D70AB9}"/>
             </a:ext>
           </a:extLst>
@@ -1054,7 +1163,7 @@
           <a:p>
             <a:fld id="{D16833E0-5E66-4D1D-89F5-BD860FDD8F71}" type="slidenum">
               <a:rPr lang="en-MY" smtClean="0"/>
-              <a:t>7</a:t>
+              <a:t>8</a:t>
             </a:fld>
             <a:endParaRPr lang="en-MY"/>
           </a:p>
@@ -1073,7 +1182,7 @@
 </p:notes>
 </file>
 
-<file path=ppt/notesSlides/notesSlide7.xml><?xml version="1.0" encoding="utf-8"?>
+<file path=ppt/notesSlides/notesSlide8.xml><?xml version="1.0" encoding="utf-8"?>
 <p:notes xmlns:a="http://schemas.openxmlformats.org/drawingml/2006/main" xmlns:r="http://schemas.openxmlformats.org/officeDocument/2006/relationships" xmlns:p="http://schemas.openxmlformats.org/presentationml/2006/main">
   <p:cSld>
     <p:spTree>
@@ -1162,7 +1271,7 @@
           <a:p>
             <a:fld id="{D16833E0-5E66-4D1D-89F5-BD860FDD8F71}" type="slidenum">
               <a:rPr lang="en-MY" smtClean="0"/>
-              <a:t>8</a:t>
+              <a:t>9</a:t>
             </a:fld>
             <a:endParaRPr lang="en-MY"/>
           </a:p>
@@ -1352,7 +1461,7 @@
           <a:p>
             <a:fld id="{1CD01395-AC05-405C-BAB9-E5D2B9FDBB40}" type="datetimeFigureOut">
               <a:rPr lang="en-MY" smtClean="0"/>
-              <a:t>15/6/2026</a:t>
+              <a:t>18/6/2026</a:t>
             </a:fld>
             <a:endParaRPr lang="en-MY"/>
           </a:p>
@@ -1667,7 +1776,7 @@
           <a:p>
             <a:fld id="{1CD01395-AC05-405C-BAB9-E5D2B9FDBB40}" type="datetimeFigureOut">
               <a:rPr lang="en-MY" smtClean="0"/>
-              <a:t>15/6/2026</a:t>
+              <a:t>18/6/2026</a:t>
             </a:fld>
             <a:endParaRPr lang="en-MY"/>
           </a:p>
@@ -1889,7 +1998,7 @@
           <a:p>
             <a:fld id="{1CD01395-AC05-405C-BAB9-E5D2B9FDBB40}" type="datetimeFigureOut">
               <a:rPr lang="en-MY" smtClean="0"/>
-              <a:t>15/6/2026</a:t>
+              <a:t>18/6/2026</a:t>
             </a:fld>
             <a:endParaRPr lang="en-MY"/>
           </a:p>
@@ -2180,7 +2289,7 @@
           <a:p>
             <a:fld id="{1CD01395-AC05-405C-BAB9-E5D2B9FDBB40}" type="datetimeFigureOut">
               <a:rPr lang="en-MY" smtClean="0"/>
-              <a:t>15/6/2026</a:t>
+              <a:t>18/6/2026</a:t>
             </a:fld>
             <a:endParaRPr lang="en-MY"/>
           </a:p>
@@ -2634,7 +2743,7 @@
           <a:p>
             <a:fld id="{1CD01395-AC05-405C-BAB9-E5D2B9FDBB40}" type="datetimeFigureOut">
               <a:rPr lang="en-MY" smtClean="0"/>
-              <a:t>15/6/2026</a:t>
+              <a:t>18/6/2026</a:t>
             </a:fld>
             <a:endParaRPr lang="en-MY"/>
           </a:p>
@@ -3210,7 +3319,7 @@
           <a:p>
             <a:fld id="{1CD01395-AC05-405C-BAB9-E5D2B9FDBB40}" type="datetimeFigureOut">
               <a:rPr lang="en-MY" smtClean="0"/>
-              <a:t>15/6/2026</a:t>
+              <a:t>18/6/2026</a:t>
             </a:fld>
             <a:endParaRPr lang="en-MY"/>
           </a:p>
@@ -4071,7 +4180,7 @@
           <a:p>
             <a:fld id="{1CD01395-AC05-405C-BAB9-E5D2B9FDBB40}" type="datetimeFigureOut">
               <a:rPr lang="en-MY" smtClean="0"/>
-              <a:t>15/6/2026</a:t>
+              <a:t>18/6/2026</a:t>
             </a:fld>
             <a:endParaRPr lang="en-MY"/>
           </a:p>
@@ -4276,7 +4385,7 @@
           <a:p>
             <a:fld id="{1CD01395-AC05-405C-BAB9-E5D2B9FDBB40}" type="datetimeFigureOut">
               <a:rPr lang="en-MY" smtClean="0"/>
-              <a:t>15/6/2026</a:t>
+              <a:t>18/6/2026</a:t>
             </a:fld>
             <a:endParaRPr lang="en-MY"/>
           </a:p>
@@ -4490,7 +4599,7 @@
           <a:p>
             <a:fld id="{1CD01395-AC05-405C-BAB9-E5D2B9FDBB40}" type="datetimeFigureOut">
               <a:rPr lang="en-MY" smtClean="0"/>
-              <a:t>15/6/2026</a:t>
+              <a:t>18/6/2026</a:t>
             </a:fld>
             <a:endParaRPr lang="en-MY"/>
           </a:p>
@@ -4695,7 +4804,7 @@
           <a:p>
             <a:fld id="{1CD01395-AC05-405C-BAB9-E5D2B9FDBB40}" type="datetimeFigureOut">
               <a:rPr lang="en-MY" smtClean="0"/>
-              <a:t>15/6/2026</a:t>
+              <a:t>18/6/2026</a:t>
             </a:fld>
             <a:endParaRPr lang="en-MY"/>
           </a:p>
@@ -4975,7 +5084,7 @@
           <a:p>
             <a:fld id="{1CD01395-AC05-405C-BAB9-E5D2B9FDBB40}" type="datetimeFigureOut">
               <a:rPr lang="en-MY" smtClean="0"/>
-              <a:t>15/6/2026</a:t>
+              <a:t>18/6/2026</a:t>
             </a:fld>
             <a:endParaRPr lang="en-MY"/>
           </a:p>
@@ -5242,7 +5351,7 @@
           <a:p>
             <a:fld id="{1CD01395-AC05-405C-BAB9-E5D2B9FDBB40}" type="datetimeFigureOut">
               <a:rPr lang="en-MY" smtClean="0"/>
-              <a:t>15/6/2026</a:t>
+              <a:t>18/6/2026</a:t>
             </a:fld>
             <a:endParaRPr lang="en-MY"/>
           </a:p>
@@ -5657,7 +5766,7 @@
           <a:p>
             <a:fld id="{1CD01395-AC05-405C-BAB9-E5D2B9FDBB40}" type="datetimeFigureOut">
               <a:rPr lang="en-MY" smtClean="0"/>
-              <a:t>15/6/2026</a:t>
+              <a:t>18/6/2026</a:t>
             </a:fld>
             <a:endParaRPr lang="en-MY"/>
           </a:p>
@@ -5805,7 +5914,7 @@
           <a:p>
             <a:fld id="{1CD01395-AC05-405C-BAB9-E5D2B9FDBB40}" type="datetimeFigureOut">
               <a:rPr lang="en-MY" smtClean="0"/>
-              <a:t>15/6/2026</a:t>
+              <a:t>18/6/2026</a:t>
             </a:fld>
             <a:endParaRPr lang="en-MY"/>
           </a:p>
@@ -5930,7 +6039,7 @@
           <a:p>
             <a:fld id="{1CD01395-AC05-405C-BAB9-E5D2B9FDBB40}" type="datetimeFigureOut">
               <a:rPr lang="en-MY" smtClean="0"/>
-              <a:t>15/6/2026</a:t>
+              <a:t>18/6/2026</a:t>
             </a:fld>
             <a:endParaRPr lang="en-MY"/>
           </a:p>
@@ -6209,7 +6318,7 @@
           <a:p>
             <a:fld id="{1CD01395-AC05-405C-BAB9-E5D2B9FDBB40}" type="datetimeFigureOut">
               <a:rPr lang="en-MY" smtClean="0"/>
-              <a:t>15/6/2026</a:t>
+              <a:t>18/6/2026</a:t>
             </a:fld>
             <a:endParaRPr lang="en-MY"/>
           </a:p>
@@ -6524,7 +6633,7 @@
           <a:p>
             <a:fld id="{1CD01395-AC05-405C-BAB9-E5D2B9FDBB40}" type="datetimeFigureOut">
               <a:rPr lang="en-MY" smtClean="0"/>
-              <a:t>15/6/2026</a:t>
+              <a:t>18/6/2026</a:t>
             </a:fld>
             <a:endParaRPr lang="en-MY"/>
           </a:p>
@@ -6777,7 +6886,7 @@
           <a:p>
             <a:fld id="{1CD01395-AC05-405C-BAB9-E5D2B9FDBB40}" type="datetimeFigureOut">
               <a:rPr lang="en-MY" smtClean="0"/>
-              <a:t>15/6/2026</a:t>
+              <a:t>18/6/2026</a:t>
             </a:fld>
             <a:endParaRPr lang="en-MY"/>
           </a:p>
@@ -7298,6 +7407,86 @@
 </p:sld>
 </file>
 
+<file path=ppt/slides/slide10.xml><?xml version="1.0" encoding="utf-8"?>
+<p:sld xmlns:a="http://schemas.openxmlformats.org/drawingml/2006/main" xmlns:r="http://schemas.openxmlformats.org/officeDocument/2006/relationships" xmlns:p="http://schemas.openxmlformats.org/presentationml/2006/main">
+  <p:cSld>
+    <p:spTree>
+      <p:nvGrpSpPr>
+        <p:cNvPr id="1" name=""/>
+        <p:cNvGrpSpPr/>
+        <p:nvPr/>
+      </p:nvGrpSpPr>
+      <p:grpSpPr>
+        <a:xfrm>
+          <a:off x="0" y="0"/>
+          <a:ext cx="0" cy="0"/>
+          <a:chOff x="0" y="0"/>
+          <a:chExt cx="0" cy="0"/>
+        </a:xfrm>
+      </p:grpSpPr>
+      <p:sp>
+        <p:nvSpPr>
+          <p:cNvPr id="2" name="Title 1">
+            <a:extLst>
+              <a:ext uri="{FF2B5EF4-FFF2-40B4-BE49-F238E27FC236}">
+                <a16:creationId xmlns:a16="http://schemas.microsoft.com/office/drawing/2014/main" id="{887D954D-6BAB-E5BB-EDE6-E99E9E8B7146}"/>
+              </a:ext>
+            </a:extLst>
+          </p:cNvPr>
+          <p:cNvSpPr>
+            <a:spLocks noGrp="1"/>
+          </p:cNvSpPr>
+          <p:nvPr>
+            <p:ph type="title"/>
+          </p:nvPr>
+        </p:nvSpPr>
+        <p:spPr/>
+        <p:txBody>
+          <a:bodyPr/>
+          <a:lstStyle/>
+          <a:p>
+            <a:endParaRPr lang="en-MY"/>
+          </a:p>
+        </p:txBody>
+      </p:sp>
+      <p:sp>
+        <p:nvSpPr>
+          <p:cNvPr id="3" name="Content Placeholder 2">
+            <a:extLst>
+              <a:ext uri="{FF2B5EF4-FFF2-40B4-BE49-F238E27FC236}">
+                <a16:creationId xmlns:a16="http://schemas.microsoft.com/office/drawing/2014/main" id="{E3051F36-2B91-1D55-6FDC-91FFF40B05A1}"/>
+              </a:ext>
+            </a:extLst>
+          </p:cNvPr>
+          <p:cNvSpPr>
+            <a:spLocks noGrp="1"/>
+          </p:cNvSpPr>
+          <p:nvPr>
+            <p:ph sz="quarter" idx="13"/>
+          </p:nvPr>
+        </p:nvSpPr>
+        <p:spPr/>
+        <p:txBody>
+          <a:bodyPr/>
+          <a:lstStyle/>
+          <a:p>
+            <a:endParaRPr lang="en-MY"/>
+          </a:p>
+        </p:txBody>
+      </p:sp>
+    </p:spTree>
+    <p:extLst>
+      <p:ext uri="{BB962C8B-B14F-4D97-AF65-F5344CB8AC3E}">
+        <p14:creationId xmlns:p14="http://schemas.microsoft.com/office/powerpoint/2010/main" val="1573312710"/>
+      </p:ext>
+    </p:extLst>
+  </p:cSld>
+  <p:clrMapOvr>
+    <a:masterClrMapping/>
+  </p:clrMapOvr>
+</p:sld>
+</file>
+
 <file path=ppt/slides/slide2.xml><?xml version="1.0" encoding="utf-8"?>
 <p:sld xmlns:a="http://schemas.openxmlformats.org/drawingml/2006/main" xmlns:r="http://schemas.openxmlformats.org/officeDocument/2006/relationships" xmlns:p="http://schemas.openxmlformats.org/presentationml/2006/main" showMasterSp="0">
   <p:cSld>
@@ -12760,8 +12949,8 @@
         </p:blipFill>
         <p:spPr>
           <a:xfrm>
-            <a:off x="2797917" y="1708493"/>
-            <a:ext cx="6596165" cy="3767163"/>
+            <a:off x="219309" y="2178819"/>
+            <a:ext cx="6172347" cy="3525115"/>
           </a:xfrm>
           <a:prstGeom prst="rect">
             <a:avLst/>
@@ -12796,7 +12985,7 @@
         </p:nvSpPr>
         <p:spPr>
           <a:xfrm>
-            <a:off x="2907498" y="730987"/>
+            <a:off x="3209250" y="292075"/>
             <a:ext cx="6102683" cy="567461"/>
           </a:xfrm>
           <a:prstGeom prst="rect">
@@ -12835,6 +13024,96 @@
               <a:t>From DB to Json</a:t>
             </a:r>
             <a:endParaRPr lang="en-MY" sz="4000" b="1" dirty="0"/>
+          </a:p>
+        </p:txBody>
+      </p:sp>
+      <p:pic>
+        <p:nvPicPr>
+          <p:cNvPr id="3" name="Picture 2">
+            <a:extLst>
+              <a:ext uri="{FF2B5EF4-FFF2-40B4-BE49-F238E27FC236}">
+                <a16:creationId xmlns:a16="http://schemas.microsoft.com/office/drawing/2014/main" id="{E7F26C49-B91E-5061-F81B-CB6DD35A7400}"/>
+              </a:ext>
+            </a:extLst>
+          </p:cNvPr>
+          <p:cNvPicPr>
+            <a:picLocks noChangeAspect="1"/>
+          </p:cNvPicPr>
+          <p:nvPr/>
+        </p:nvPicPr>
+        <p:blipFill>
+          <a:blip r:embed="rId4"/>
+          <a:srcRect r="29937"/>
+          <a:stretch>
+            <a:fillRect/>
+          </a:stretch>
+        </p:blipFill>
+        <p:spPr>
+          <a:xfrm>
+            <a:off x="8749895" y="1688399"/>
+            <a:ext cx="2542945" cy="4505954"/>
+          </a:xfrm>
+          <a:prstGeom prst="rect">
+            <a:avLst/>
+          </a:prstGeom>
+          <a:ln w="127000" cap="sq">
+            <a:solidFill>
+              <a:srgbClr val="000000"/>
+            </a:solidFill>
+            <a:miter lim="800000"/>
+          </a:ln>
+          <a:effectLst>
+            <a:outerShdw blurRad="57150" dist="50800" dir="2700000" algn="tl" rotWithShape="0">
+              <a:srgbClr val="000000">
+                <a:alpha val="40000"/>
+              </a:srgbClr>
+            </a:outerShdw>
+          </a:effectLst>
+        </p:spPr>
+      </p:pic>
+      <p:sp>
+        <p:nvSpPr>
+          <p:cNvPr id="4" name="Arrow: Right 3">
+            <a:extLst>
+              <a:ext uri="{FF2B5EF4-FFF2-40B4-BE49-F238E27FC236}">
+                <a16:creationId xmlns:a16="http://schemas.microsoft.com/office/drawing/2014/main" id="{CC88C422-744D-5DCF-988F-D10AD46473D5}"/>
+              </a:ext>
+            </a:extLst>
+          </p:cNvPr>
+          <p:cNvSpPr/>
+          <p:nvPr/>
+        </p:nvSpPr>
+        <p:spPr>
+          <a:xfrm>
+            <a:off x="6903720" y="3346704"/>
+            <a:ext cx="1325880" cy="731520"/>
+          </a:xfrm>
+          <a:prstGeom prst="rightArrow">
+            <a:avLst/>
+          </a:prstGeom>
+        </p:spPr>
+        <p:style>
+          <a:lnRef idx="2">
+            <a:schemeClr val="accent1">
+              <a:shade val="15000"/>
+            </a:schemeClr>
+          </a:lnRef>
+          <a:fillRef idx="1">
+            <a:schemeClr val="accent1"/>
+          </a:fillRef>
+          <a:effectRef idx="0">
+            <a:schemeClr val="accent1"/>
+          </a:effectRef>
+          <a:fontRef idx="minor">
+            <a:schemeClr val="lt1"/>
+          </a:fontRef>
+        </p:style>
+        <p:txBody>
+          <a:bodyPr rtlCol="0" anchor="ctr"/>
+          <a:lstStyle/>
+          <a:p>
+            <a:pPr algn="ctr"/>
+            <a:endParaRPr lang="en-MY"/>
           </a:p>
         </p:txBody>
       </p:sp>
@@ -12885,6 +13164,49 @@
           <a:chExt cx="0" cy="0"/>
         </a:xfrm>
       </p:grpSpPr>
+      <p:pic>
+        <p:nvPicPr>
+          <p:cNvPr id="3" name="Picture 2">
+            <a:extLst>
+              <a:ext uri="{FF2B5EF4-FFF2-40B4-BE49-F238E27FC236}">
+                <a16:creationId xmlns:a16="http://schemas.microsoft.com/office/drawing/2014/main" id="{D9B802F5-DEEB-EEB0-FF97-A42EB4EB2FBB}"/>
+              </a:ext>
+            </a:extLst>
+          </p:cNvPr>
+          <p:cNvPicPr>
+            <a:picLocks noChangeAspect="1"/>
+          </p:cNvPicPr>
+          <p:nvPr/>
+        </p:nvPicPr>
+        <p:blipFill>
+          <a:blip r:embed="rId3"/>
+          <a:stretch>
+            <a:fillRect/>
+          </a:stretch>
+        </p:blipFill>
+        <p:spPr>
+          <a:xfrm>
+            <a:off x="574138" y="954783"/>
+            <a:ext cx="5868219" cy="2772162"/>
+          </a:xfrm>
+          <a:prstGeom prst="rect">
+            <a:avLst/>
+          </a:prstGeom>
+          <a:ln w="127000" cap="sq">
+            <a:solidFill>
+              <a:srgbClr val="000000"/>
+            </a:solidFill>
+            <a:miter lim="800000"/>
+          </a:ln>
+          <a:effectLst>
+            <a:outerShdw blurRad="57150" dist="50800" dir="2700000" algn="tl" rotWithShape="0">
+              <a:srgbClr val="000000">
+                <a:alpha val="40000"/>
+              </a:srgbClr>
+            </a:outerShdw>
+          </a:effectLst>
+        </p:spPr>
+      </p:pic>
     </p:spTree>
     <p:extLst>
       <p:ext uri="{BB962C8B-B14F-4D97-AF65-F5344CB8AC3E}">
@@ -12899,6 +13221,90 @@
 </file>
 
 <file path=ppt/slides/slide7.xml><?xml version="1.0" encoding="utf-8"?>
+<p:sld xmlns:a="http://schemas.openxmlformats.org/drawingml/2006/main" xmlns:r="http://schemas.openxmlformats.org/officeDocument/2006/relationships" xmlns:p="http://schemas.openxmlformats.org/presentationml/2006/main" showMasterSp="0">
+  <p:cSld>
+    <p:bg>
+      <p:bgPr>
+        <a:solidFill>
+          <a:schemeClr val="accent6">
+            <a:lumMod val="20000"/>
+            <a:lumOff val="80000"/>
+          </a:schemeClr>
+        </a:solidFill>
+        <a:effectLst/>
+      </p:bgPr>
+    </p:bg>
+    <p:spTree>
+      <p:nvGrpSpPr>
+        <p:cNvPr id="1" name="">
+          <a:extLst>
+            <a:ext uri="{FF2B5EF4-FFF2-40B4-BE49-F238E27FC236}">
+              <a16:creationId xmlns:a16="http://schemas.microsoft.com/office/drawing/2014/main" id="{BF222BB4-E5E8-E925-90A0-2C3082D2E871}"/>
+            </a:ext>
+          </a:extLst>
+        </p:cNvPr>
+        <p:cNvGrpSpPr/>
+        <p:nvPr/>
+      </p:nvGrpSpPr>
+      <p:grpSpPr>
+        <a:xfrm>
+          <a:off x="0" y="0"/>
+          <a:ext cx="0" cy="0"/>
+          <a:chOff x="0" y="0"/>
+          <a:chExt cx="0" cy="0"/>
+        </a:xfrm>
+      </p:grpSpPr>
+      <p:pic>
+        <p:nvPicPr>
+          <p:cNvPr id="6" name="Picture 5">
+            <a:extLst>
+              <a:ext uri="{FF2B5EF4-FFF2-40B4-BE49-F238E27FC236}">
+                <a16:creationId xmlns:a16="http://schemas.microsoft.com/office/drawing/2014/main" id="{A07C17FA-B6A8-B16D-4963-8E376401C32F}"/>
+              </a:ext>
+            </a:extLst>
+          </p:cNvPr>
+          <p:cNvPicPr>
+            <a:picLocks noChangeAspect="1"/>
+          </p:cNvPicPr>
+          <p:nvPr/>
+        </p:nvPicPr>
+        <p:blipFill>
+          <a:blip r:embed="rId3">
+            <a:extLst>
+              <a:ext uri="{28A0092B-C50C-407E-A947-70E740481C1C}">
+                <a14:useLocalDpi xmlns:a14="http://schemas.microsoft.com/office/drawing/2010/main" val="0"/>
+              </a:ext>
+            </a:extLst>
+          </a:blip>
+          <a:srcRect l="17625" t="537" r="17350" b="-537"/>
+          <a:stretch>
+            <a:fillRect/>
+          </a:stretch>
+        </p:blipFill>
+        <p:spPr>
+          <a:xfrm>
+            <a:off x="2990088" y="703237"/>
+            <a:ext cx="5577840" cy="4787717"/>
+          </a:xfrm>
+          <a:prstGeom prst="rect">
+            <a:avLst/>
+          </a:prstGeom>
+        </p:spPr>
+      </p:pic>
+    </p:spTree>
+    <p:extLst>
+      <p:ext uri="{BB962C8B-B14F-4D97-AF65-F5344CB8AC3E}">
+        <p14:creationId xmlns:p14="http://schemas.microsoft.com/office/powerpoint/2010/main" val="1157750540"/>
+      </p:ext>
+    </p:extLst>
+  </p:cSld>
+  <p:clrMapOvr>
+    <a:masterClrMapping/>
+  </p:clrMapOvr>
+</p:sld>
+</file>
+
+<file path=ppt/slides/slide8.xml><?xml version="1.0" encoding="utf-8"?>
 <p:sld xmlns:a="http://schemas.openxmlformats.org/drawingml/2006/main" xmlns:r="http://schemas.openxmlformats.org/officeDocument/2006/relationships" xmlns:p="http://schemas.openxmlformats.org/presentationml/2006/main" showMasterSp="0">
   <p:cSld>
     <p:bg>
@@ -13033,7 +13439,7 @@
 </p:sld>
 </file>
 
-<file path=ppt/slides/slide8.xml><?xml version="1.0" encoding="utf-8"?>
+<file path=ppt/slides/slide9.xml><?xml version="1.0" encoding="utf-8"?>
 <p:sld xmlns:a="http://schemas.openxmlformats.org/drawingml/2006/main" xmlns:r="http://schemas.openxmlformats.org/officeDocument/2006/relationships" xmlns:p="http://schemas.openxmlformats.org/presentationml/2006/main" showMasterSp="0">
   <p:cSld>
     <p:bg>
@@ -13139,86 +13545,6 @@
     <p:extLst>
       <p:ext uri="{BB962C8B-B14F-4D97-AF65-F5344CB8AC3E}">
         <p14:creationId xmlns:p14="http://schemas.microsoft.com/office/powerpoint/2010/main" val="975718132"/>
-      </p:ext>
-    </p:extLst>
-  </p:cSld>
-  <p:clrMapOvr>
-    <a:masterClrMapping/>
-  </p:clrMapOvr>
-</p:sld>
-</file>
-
-<file path=ppt/slides/slide9.xml><?xml version="1.0" encoding="utf-8"?>
-<p:sld xmlns:a="http://schemas.openxmlformats.org/drawingml/2006/main" xmlns:r="http://schemas.openxmlformats.org/officeDocument/2006/relationships" xmlns:p="http://schemas.openxmlformats.org/presentationml/2006/main">
-  <p:cSld>
-    <p:spTree>
-      <p:nvGrpSpPr>
-        <p:cNvPr id="1" name=""/>
-        <p:cNvGrpSpPr/>
-        <p:nvPr/>
-      </p:nvGrpSpPr>
-      <p:grpSpPr>
-        <a:xfrm>
-          <a:off x="0" y="0"/>
-          <a:ext cx="0" cy="0"/>
-          <a:chOff x="0" y="0"/>
-          <a:chExt cx="0" cy="0"/>
-        </a:xfrm>
-      </p:grpSpPr>
-      <p:sp>
-        <p:nvSpPr>
-          <p:cNvPr id="2" name="Title 1">
-            <a:extLst>
-              <a:ext uri="{FF2B5EF4-FFF2-40B4-BE49-F238E27FC236}">
-                <a16:creationId xmlns:a16="http://schemas.microsoft.com/office/drawing/2014/main" id="{887D954D-6BAB-E5BB-EDE6-E99E9E8B7146}"/>
-              </a:ext>
-            </a:extLst>
-          </p:cNvPr>
-          <p:cNvSpPr>
-            <a:spLocks noGrp="1"/>
-          </p:cNvSpPr>
-          <p:nvPr>
-            <p:ph type="title"/>
-          </p:nvPr>
-        </p:nvSpPr>
-        <p:spPr/>
-        <p:txBody>
-          <a:bodyPr/>
-          <a:lstStyle/>
-          <a:p>
-            <a:endParaRPr lang="en-MY"/>
-          </a:p>
-        </p:txBody>
-      </p:sp>
-      <p:sp>
-        <p:nvSpPr>
-          <p:cNvPr id="3" name="Content Placeholder 2">
-            <a:extLst>
-              <a:ext uri="{FF2B5EF4-FFF2-40B4-BE49-F238E27FC236}">
-                <a16:creationId xmlns:a16="http://schemas.microsoft.com/office/drawing/2014/main" id="{E3051F36-2B91-1D55-6FDC-91FFF40B05A1}"/>
-              </a:ext>
-            </a:extLst>
-          </p:cNvPr>
-          <p:cNvSpPr>
-            <a:spLocks noGrp="1"/>
-          </p:cNvSpPr>
-          <p:nvPr>
-            <p:ph sz="quarter" idx="13"/>
-          </p:nvPr>
-        </p:nvSpPr>
-        <p:spPr/>
-        <p:txBody>
-          <a:bodyPr/>
-          <a:lstStyle/>
-          <a:p>
-            <a:endParaRPr lang="en-MY"/>
-          </a:p>
-        </p:txBody>
-      </p:sp>
-    </p:spTree>
-    <p:extLst>
-      <p:ext uri="{BB962C8B-B14F-4D97-AF65-F5344CB8AC3E}">
-        <p14:creationId xmlns:p14="http://schemas.microsoft.com/office/powerpoint/2010/main" val="1573312710"/>
       </p:ext>
     </p:extLst>
   </p:cSld>

</xml_diff>

<commit_message>
update script - Program.cs
</commit_message>
<xml_diff>
--- a/1.training_model/supplementary/Device Identifier 20260520.pptx
+++ b/1.training_model/supplementary/Device Identifier 20260520.pptx
@@ -5,7 +5,7 @@
     <p:sldMasterId id="2147483696" r:id="rId1"/>
   </p:sldMasterIdLst>
   <p:notesMasterIdLst>
-    <p:notesMasterId r:id="rId12"/>
+    <p:notesMasterId r:id="rId13"/>
   </p:notesMasterIdLst>
   <p:sldIdLst>
     <p:sldId id="256" r:id="rId2"/>
@@ -17,7 +17,8 @@
     <p:sldId id="331" r:id="rId8"/>
     <p:sldId id="323" r:id="rId9"/>
     <p:sldId id="327" r:id="rId10"/>
-    <p:sldId id="326" r:id="rId11"/>
+    <p:sldId id="332" r:id="rId11"/>
+    <p:sldId id="326" r:id="rId12"/>
   </p:sldIdLst>
   <p:sldSz cx="12192000" cy="6858000"/>
   <p:notesSz cx="6858000" cy="9144000"/>
@@ -206,7 +207,7 @@
           <a:p>
             <a:fld id="{23D8B80A-F233-4240-BDAF-6537AE249829}" type="datetimeFigureOut">
               <a:rPr lang="en-MY" smtClean="0"/>
-              <a:t>18/6/2026</a:t>
+              <a:t>19/6/2026</a:t>
             </a:fld>
             <a:endParaRPr lang="en-MY"/>
           </a:p>
@@ -1290,6 +1291,114 @@
 </p:notes>
 </file>
 
+<file path=ppt/notesSlides/notesSlide9.xml><?xml version="1.0" encoding="utf-8"?>
+<p:notes xmlns:a="http://schemas.openxmlformats.org/drawingml/2006/main" xmlns:r="http://schemas.openxmlformats.org/officeDocument/2006/relationships" xmlns:p="http://schemas.openxmlformats.org/presentationml/2006/main">
+  <p:cSld>
+    <p:spTree>
+      <p:nvGrpSpPr>
+        <p:cNvPr id="1" name="">
+          <a:extLst>
+            <a:ext uri="{FF2B5EF4-FFF2-40B4-BE49-F238E27FC236}">
+              <a16:creationId xmlns:a16="http://schemas.microsoft.com/office/drawing/2014/main" id="{AA54A910-8722-BE0D-ECC6-AE331ECADDCC}"/>
+            </a:ext>
+          </a:extLst>
+        </p:cNvPr>
+        <p:cNvGrpSpPr/>
+        <p:nvPr/>
+      </p:nvGrpSpPr>
+      <p:grpSpPr>
+        <a:xfrm>
+          <a:off x="0" y="0"/>
+          <a:ext cx="0" cy="0"/>
+          <a:chOff x="0" y="0"/>
+          <a:chExt cx="0" cy="0"/>
+        </a:xfrm>
+      </p:grpSpPr>
+      <p:sp>
+        <p:nvSpPr>
+          <p:cNvPr id="2" name="Slide Image Placeholder 1">
+            <a:extLst>
+              <a:ext uri="{FF2B5EF4-FFF2-40B4-BE49-F238E27FC236}">
+                <a16:creationId xmlns:a16="http://schemas.microsoft.com/office/drawing/2014/main" id="{C9FF1B51-0D4E-F4D9-C462-F4905C8AAF9C}"/>
+              </a:ext>
+            </a:extLst>
+          </p:cNvPr>
+          <p:cNvSpPr>
+            <a:spLocks noGrp="1" noRot="1" noChangeAspect="1"/>
+          </p:cNvSpPr>
+          <p:nvPr>
+            <p:ph type="sldImg"/>
+          </p:nvPr>
+        </p:nvSpPr>
+        <p:spPr/>
+      </p:sp>
+      <p:sp>
+        <p:nvSpPr>
+          <p:cNvPr id="3" name="Notes Placeholder 2">
+            <a:extLst>
+              <a:ext uri="{FF2B5EF4-FFF2-40B4-BE49-F238E27FC236}">
+                <a16:creationId xmlns:a16="http://schemas.microsoft.com/office/drawing/2014/main" id="{C41BCF9F-3AF4-EF24-64C9-01366B660CC8}"/>
+              </a:ext>
+            </a:extLst>
+          </p:cNvPr>
+          <p:cNvSpPr>
+            <a:spLocks noGrp="1"/>
+          </p:cNvSpPr>
+          <p:nvPr>
+            <p:ph type="body" idx="1"/>
+          </p:nvPr>
+        </p:nvSpPr>
+        <p:spPr/>
+        <p:txBody>
+          <a:bodyPr/>
+          <a:lstStyle/>
+          <a:p>
+            <a:endParaRPr lang="en-MY" dirty="0"/>
+          </a:p>
+        </p:txBody>
+      </p:sp>
+      <p:sp>
+        <p:nvSpPr>
+          <p:cNvPr id="4" name="Slide Number Placeholder 3">
+            <a:extLst>
+              <a:ext uri="{FF2B5EF4-FFF2-40B4-BE49-F238E27FC236}">
+                <a16:creationId xmlns:a16="http://schemas.microsoft.com/office/drawing/2014/main" id="{7A6CF6CA-73F6-4CE7-341F-2286B37A0478}"/>
+              </a:ext>
+            </a:extLst>
+          </p:cNvPr>
+          <p:cNvSpPr>
+            <a:spLocks noGrp="1"/>
+          </p:cNvSpPr>
+          <p:nvPr>
+            <p:ph type="sldNum" sz="quarter" idx="5"/>
+          </p:nvPr>
+        </p:nvSpPr>
+        <p:spPr/>
+        <p:txBody>
+          <a:bodyPr/>
+          <a:lstStyle/>
+          <a:p>
+            <a:fld id="{D16833E0-5E66-4D1D-89F5-BD860FDD8F71}" type="slidenum">
+              <a:rPr lang="en-MY" smtClean="0"/>
+              <a:t>10</a:t>
+            </a:fld>
+            <a:endParaRPr lang="en-MY"/>
+          </a:p>
+        </p:txBody>
+      </p:sp>
+    </p:spTree>
+    <p:extLst>
+      <p:ext uri="{BB962C8B-B14F-4D97-AF65-F5344CB8AC3E}">
+        <p14:creationId xmlns:p14="http://schemas.microsoft.com/office/powerpoint/2010/main" val="4002248972"/>
+      </p:ext>
+    </p:extLst>
+  </p:cSld>
+  <p:clrMapOvr>
+    <a:masterClrMapping/>
+  </p:clrMapOvr>
+</p:notes>
+</file>
+
 <file path=ppt/slideLayouts/slideLayout1.xml><?xml version="1.0" encoding="utf-8"?>
 <p:sldLayout xmlns:a="http://schemas.openxmlformats.org/drawingml/2006/main" xmlns:r="http://schemas.openxmlformats.org/officeDocument/2006/relationships" xmlns:p="http://schemas.openxmlformats.org/presentationml/2006/main" type="title" preserve="1">
   <p:cSld name="Title Slide">
@@ -1461,7 +1570,7 @@
           <a:p>
             <a:fld id="{1CD01395-AC05-405C-BAB9-E5D2B9FDBB40}" type="datetimeFigureOut">
               <a:rPr lang="en-MY" smtClean="0"/>
-              <a:t>18/6/2026</a:t>
+              <a:t>19/6/2026</a:t>
             </a:fld>
             <a:endParaRPr lang="en-MY"/>
           </a:p>
@@ -1776,7 +1885,7 @@
           <a:p>
             <a:fld id="{1CD01395-AC05-405C-BAB9-E5D2B9FDBB40}" type="datetimeFigureOut">
               <a:rPr lang="en-MY" smtClean="0"/>
-              <a:t>18/6/2026</a:t>
+              <a:t>19/6/2026</a:t>
             </a:fld>
             <a:endParaRPr lang="en-MY"/>
           </a:p>
@@ -1998,7 +2107,7 @@
           <a:p>
             <a:fld id="{1CD01395-AC05-405C-BAB9-E5D2B9FDBB40}" type="datetimeFigureOut">
               <a:rPr lang="en-MY" smtClean="0"/>
-              <a:t>18/6/2026</a:t>
+              <a:t>19/6/2026</a:t>
             </a:fld>
             <a:endParaRPr lang="en-MY"/>
           </a:p>
@@ -2289,7 +2398,7 @@
           <a:p>
             <a:fld id="{1CD01395-AC05-405C-BAB9-E5D2B9FDBB40}" type="datetimeFigureOut">
               <a:rPr lang="en-MY" smtClean="0"/>
-              <a:t>18/6/2026</a:t>
+              <a:t>19/6/2026</a:t>
             </a:fld>
             <a:endParaRPr lang="en-MY"/>
           </a:p>
@@ -2743,7 +2852,7 @@
           <a:p>
             <a:fld id="{1CD01395-AC05-405C-BAB9-E5D2B9FDBB40}" type="datetimeFigureOut">
               <a:rPr lang="en-MY" smtClean="0"/>
-              <a:t>18/6/2026</a:t>
+              <a:t>19/6/2026</a:t>
             </a:fld>
             <a:endParaRPr lang="en-MY"/>
           </a:p>
@@ -3319,7 +3428,7 @@
           <a:p>
             <a:fld id="{1CD01395-AC05-405C-BAB9-E5D2B9FDBB40}" type="datetimeFigureOut">
               <a:rPr lang="en-MY" smtClean="0"/>
-              <a:t>18/6/2026</a:t>
+              <a:t>19/6/2026</a:t>
             </a:fld>
             <a:endParaRPr lang="en-MY"/>
           </a:p>
@@ -4180,7 +4289,7 @@
           <a:p>
             <a:fld id="{1CD01395-AC05-405C-BAB9-E5D2B9FDBB40}" type="datetimeFigureOut">
               <a:rPr lang="en-MY" smtClean="0"/>
-              <a:t>18/6/2026</a:t>
+              <a:t>19/6/2026</a:t>
             </a:fld>
             <a:endParaRPr lang="en-MY"/>
           </a:p>
@@ -4385,7 +4494,7 @@
           <a:p>
             <a:fld id="{1CD01395-AC05-405C-BAB9-E5D2B9FDBB40}" type="datetimeFigureOut">
               <a:rPr lang="en-MY" smtClean="0"/>
-              <a:t>18/6/2026</a:t>
+              <a:t>19/6/2026</a:t>
             </a:fld>
             <a:endParaRPr lang="en-MY"/>
           </a:p>
@@ -4599,7 +4708,7 @@
           <a:p>
             <a:fld id="{1CD01395-AC05-405C-BAB9-E5D2B9FDBB40}" type="datetimeFigureOut">
               <a:rPr lang="en-MY" smtClean="0"/>
-              <a:t>18/6/2026</a:t>
+              <a:t>19/6/2026</a:t>
             </a:fld>
             <a:endParaRPr lang="en-MY"/>
           </a:p>
@@ -4804,7 +4913,7 @@
           <a:p>
             <a:fld id="{1CD01395-AC05-405C-BAB9-E5D2B9FDBB40}" type="datetimeFigureOut">
               <a:rPr lang="en-MY" smtClean="0"/>
-              <a:t>18/6/2026</a:t>
+              <a:t>19/6/2026</a:t>
             </a:fld>
             <a:endParaRPr lang="en-MY"/>
           </a:p>
@@ -5084,7 +5193,7 @@
           <a:p>
             <a:fld id="{1CD01395-AC05-405C-BAB9-E5D2B9FDBB40}" type="datetimeFigureOut">
               <a:rPr lang="en-MY" smtClean="0"/>
-              <a:t>18/6/2026</a:t>
+              <a:t>19/6/2026</a:t>
             </a:fld>
             <a:endParaRPr lang="en-MY"/>
           </a:p>
@@ -5351,7 +5460,7 @@
           <a:p>
             <a:fld id="{1CD01395-AC05-405C-BAB9-E5D2B9FDBB40}" type="datetimeFigureOut">
               <a:rPr lang="en-MY" smtClean="0"/>
-              <a:t>18/6/2026</a:t>
+              <a:t>19/6/2026</a:t>
             </a:fld>
             <a:endParaRPr lang="en-MY"/>
           </a:p>
@@ -5766,7 +5875,7 @@
           <a:p>
             <a:fld id="{1CD01395-AC05-405C-BAB9-E5D2B9FDBB40}" type="datetimeFigureOut">
               <a:rPr lang="en-MY" smtClean="0"/>
-              <a:t>18/6/2026</a:t>
+              <a:t>19/6/2026</a:t>
             </a:fld>
             <a:endParaRPr lang="en-MY"/>
           </a:p>
@@ -5914,7 +6023,7 @@
           <a:p>
             <a:fld id="{1CD01395-AC05-405C-BAB9-E5D2B9FDBB40}" type="datetimeFigureOut">
               <a:rPr lang="en-MY" smtClean="0"/>
-              <a:t>18/6/2026</a:t>
+              <a:t>19/6/2026</a:t>
             </a:fld>
             <a:endParaRPr lang="en-MY"/>
           </a:p>
@@ -6039,7 +6148,7 @@
           <a:p>
             <a:fld id="{1CD01395-AC05-405C-BAB9-E5D2B9FDBB40}" type="datetimeFigureOut">
               <a:rPr lang="en-MY" smtClean="0"/>
-              <a:t>18/6/2026</a:t>
+              <a:t>19/6/2026</a:t>
             </a:fld>
             <a:endParaRPr lang="en-MY"/>
           </a:p>
@@ -6318,7 +6427,7 @@
           <a:p>
             <a:fld id="{1CD01395-AC05-405C-BAB9-E5D2B9FDBB40}" type="datetimeFigureOut">
               <a:rPr lang="en-MY" smtClean="0"/>
-              <a:t>18/6/2026</a:t>
+              <a:t>19/6/2026</a:t>
             </a:fld>
             <a:endParaRPr lang="en-MY"/>
           </a:p>
@@ -6633,7 +6742,7 @@
           <a:p>
             <a:fld id="{1CD01395-AC05-405C-BAB9-E5D2B9FDBB40}" type="datetimeFigureOut">
               <a:rPr lang="en-MY" smtClean="0"/>
-              <a:t>18/6/2026</a:t>
+              <a:t>19/6/2026</a:t>
             </a:fld>
             <a:endParaRPr lang="en-MY"/>
           </a:p>
@@ -6886,7 +6995,7 @@
           <a:p>
             <a:fld id="{1CD01395-AC05-405C-BAB9-E5D2B9FDBB40}" type="datetimeFigureOut">
               <a:rPr lang="en-MY" smtClean="0"/>
-              <a:t>18/6/2026</a:t>
+              <a:t>19/6/2026</a:t>
             </a:fld>
             <a:endParaRPr lang="en-MY"/>
           </a:p>
@@ -7408,6 +7517,80 @@
 </file>
 
 <file path=ppt/slides/slide10.xml><?xml version="1.0" encoding="utf-8"?>
+<p:sld xmlns:a="http://schemas.openxmlformats.org/drawingml/2006/main" xmlns:r="http://schemas.openxmlformats.org/officeDocument/2006/relationships" xmlns:p="http://schemas.openxmlformats.org/presentationml/2006/main" showMasterSp="0">
+  <p:cSld>
+    <p:bg>
+      <p:bgPr>
+        <a:solidFill>
+          <a:schemeClr val="bg1"/>
+        </a:solidFill>
+        <a:effectLst/>
+      </p:bgPr>
+    </p:bg>
+    <p:spTree>
+      <p:nvGrpSpPr>
+        <p:cNvPr id="1" name="">
+          <a:extLst>
+            <a:ext uri="{FF2B5EF4-FFF2-40B4-BE49-F238E27FC236}">
+              <a16:creationId xmlns:a16="http://schemas.microsoft.com/office/drawing/2014/main" id="{F0F2548E-9A0F-EFA7-4A68-4D96B0D0C79A}"/>
+            </a:ext>
+          </a:extLst>
+        </p:cNvPr>
+        <p:cNvGrpSpPr/>
+        <p:nvPr/>
+      </p:nvGrpSpPr>
+      <p:grpSpPr>
+        <a:xfrm>
+          <a:off x="0" y="0"/>
+          <a:ext cx="0" cy="0"/>
+          <a:chOff x="0" y="0"/>
+          <a:chExt cx="0" cy="0"/>
+        </a:xfrm>
+      </p:grpSpPr>
+      <p:pic>
+        <p:nvPicPr>
+          <p:cNvPr id="5" name="Picture 4">
+            <a:extLst>
+              <a:ext uri="{FF2B5EF4-FFF2-40B4-BE49-F238E27FC236}">
+                <a16:creationId xmlns:a16="http://schemas.microsoft.com/office/drawing/2014/main" id="{4993614A-CAD1-31A5-3EFA-9390AA2C9D9F}"/>
+              </a:ext>
+            </a:extLst>
+          </p:cNvPr>
+          <p:cNvPicPr>
+            <a:picLocks noChangeAspect="1"/>
+          </p:cNvPicPr>
+          <p:nvPr/>
+        </p:nvPicPr>
+        <p:blipFill>
+          <a:blip r:embed="rId3"/>
+          <a:stretch>
+            <a:fillRect/>
+          </a:stretch>
+        </p:blipFill>
+        <p:spPr>
+          <a:xfrm>
+            <a:off x="4327523" y="137160"/>
+            <a:ext cx="3536954" cy="6331890"/>
+          </a:xfrm>
+          <a:prstGeom prst="rect">
+            <a:avLst/>
+          </a:prstGeom>
+        </p:spPr>
+      </p:pic>
+    </p:spTree>
+    <p:extLst>
+      <p:ext uri="{BB962C8B-B14F-4D97-AF65-F5344CB8AC3E}">
+        <p14:creationId xmlns:p14="http://schemas.microsoft.com/office/powerpoint/2010/main" val="3829516895"/>
+      </p:ext>
+    </p:extLst>
+  </p:cSld>
+  <p:clrMapOvr>
+    <a:masterClrMapping/>
+  </p:clrMapOvr>
+</p:sld>
+</file>
+
+<file path=ppt/slides/slide11.xml><?xml version="1.0" encoding="utf-8"?>
 <p:sld xmlns:a="http://schemas.openxmlformats.org/drawingml/2006/main" xmlns:r="http://schemas.openxmlformats.org/officeDocument/2006/relationships" xmlns:p="http://schemas.openxmlformats.org/presentationml/2006/main">
   <p:cSld>
     <p:spTree>

</xml_diff>

<commit_message>
update - slide ppt
</commit_message>
<xml_diff>
--- a/1.training_model/supplementary/Device Identifier 20260520.pptx
+++ b/1.training_model/supplementary/Device Identifier 20260520.pptx
@@ -15,9 +15,9 @@
     <p:sldId id="329" r:id="rId6"/>
     <p:sldId id="330" r:id="rId7"/>
     <p:sldId id="331" r:id="rId8"/>
-    <p:sldId id="323" r:id="rId9"/>
-    <p:sldId id="327" r:id="rId10"/>
-    <p:sldId id="332" r:id="rId11"/>
+    <p:sldId id="332" r:id="rId9"/>
+    <p:sldId id="323" r:id="rId10"/>
+    <p:sldId id="327" r:id="rId11"/>
     <p:sldId id="326" r:id="rId12"/>
   </p:sldIdLst>
   <p:sldSz cx="12192000" cy="6858000"/>
@@ -207,7 +207,7 @@
           <a:p>
             <a:fld id="{23D8B80A-F233-4240-BDAF-6537AE249829}" type="datetimeFigureOut">
               <a:rPr lang="en-MY" smtClean="0"/>
-              <a:t>19/6/2026</a:t>
+              <a:t>22/6/2026</a:t>
             </a:fld>
             <a:endParaRPr lang="en-MY"/>
           </a:p>
@@ -1083,6 +1083,114 @@
         <p:cNvPr id="1" name="">
           <a:extLst>
             <a:ext uri="{FF2B5EF4-FFF2-40B4-BE49-F238E27FC236}">
+              <a16:creationId xmlns:a16="http://schemas.microsoft.com/office/drawing/2014/main" id="{AA54A910-8722-BE0D-ECC6-AE331ECADDCC}"/>
+            </a:ext>
+          </a:extLst>
+        </p:cNvPr>
+        <p:cNvGrpSpPr/>
+        <p:nvPr/>
+      </p:nvGrpSpPr>
+      <p:grpSpPr>
+        <a:xfrm>
+          <a:off x="0" y="0"/>
+          <a:ext cx="0" cy="0"/>
+          <a:chOff x="0" y="0"/>
+          <a:chExt cx="0" cy="0"/>
+        </a:xfrm>
+      </p:grpSpPr>
+      <p:sp>
+        <p:nvSpPr>
+          <p:cNvPr id="2" name="Slide Image Placeholder 1">
+            <a:extLst>
+              <a:ext uri="{FF2B5EF4-FFF2-40B4-BE49-F238E27FC236}">
+                <a16:creationId xmlns:a16="http://schemas.microsoft.com/office/drawing/2014/main" id="{C9FF1B51-0D4E-F4D9-C462-F4905C8AAF9C}"/>
+              </a:ext>
+            </a:extLst>
+          </p:cNvPr>
+          <p:cNvSpPr>
+            <a:spLocks noGrp="1" noRot="1" noChangeAspect="1"/>
+          </p:cNvSpPr>
+          <p:nvPr>
+            <p:ph type="sldImg"/>
+          </p:nvPr>
+        </p:nvSpPr>
+        <p:spPr/>
+      </p:sp>
+      <p:sp>
+        <p:nvSpPr>
+          <p:cNvPr id="3" name="Notes Placeholder 2">
+            <a:extLst>
+              <a:ext uri="{FF2B5EF4-FFF2-40B4-BE49-F238E27FC236}">
+                <a16:creationId xmlns:a16="http://schemas.microsoft.com/office/drawing/2014/main" id="{C41BCF9F-3AF4-EF24-64C9-01366B660CC8}"/>
+              </a:ext>
+            </a:extLst>
+          </p:cNvPr>
+          <p:cNvSpPr>
+            <a:spLocks noGrp="1"/>
+          </p:cNvSpPr>
+          <p:nvPr>
+            <p:ph type="body" idx="1"/>
+          </p:nvPr>
+        </p:nvSpPr>
+        <p:spPr/>
+        <p:txBody>
+          <a:bodyPr/>
+          <a:lstStyle/>
+          <a:p>
+            <a:endParaRPr lang="en-MY" dirty="0"/>
+          </a:p>
+        </p:txBody>
+      </p:sp>
+      <p:sp>
+        <p:nvSpPr>
+          <p:cNvPr id="4" name="Slide Number Placeholder 3">
+            <a:extLst>
+              <a:ext uri="{FF2B5EF4-FFF2-40B4-BE49-F238E27FC236}">
+                <a16:creationId xmlns:a16="http://schemas.microsoft.com/office/drawing/2014/main" id="{7A6CF6CA-73F6-4CE7-341F-2286B37A0478}"/>
+              </a:ext>
+            </a:extLst>
+          </p:cNvPr>
+          <p:cNvSpPr>
+            <a:spLocks noGrp="1"/>
+          </p:cNvSpPr>
+          <p:nvPr>
+            <p:ph type="sldNum" sz="quarter" idx="5"/>
+          </p:nvPr>
+        </p:nvSpPr>
+        <p:spPr/>
+        <p:txBody>
+          <a:bodyPr/>
+          <a:lstStyle/>
+          <a:p>
+            <a:fld id="{D16833E0-5E66-4D1D-89F5-BD860FDD8F71}" type="slidenum">
+              <a:rPr lang="en-MY" smtClean="0"/>
+              <a:t>8</a:t>
+            </a:fld>
+            <a:endParaRPr lang="en-MY"/>
+          </a:p>
+        </p:txBody>
+      </p:sp>
+    </p:spTree>
+    <p:extLst>
+      <p:ext uri="{BB962C8B-B14F-4D97-AF65-F5344CB8AC3E}">
+        <p14:creationId xmlns:p14="http://schemas.microsoft.com/office/powerpoint/2010/main" val="4002248972"/>
+      </p:ext>
+    </p:extLst>
+  </p:cSld>
+  <p:clrMapOvr>
+    <a:masterClrMapping/>
+  </p:clrMapOvr>
+</p:notes>
+</file>
+
+<file path=ppt/notesSlides/notesSlide8.xml><?xml version="1.0" encoding="utf-8"?>
+<p:notes xmlns:a="http://schemas.openxmlformats.org/drawingml/2006/main" xmlns:r="http://schemas.openxmlformats.org/officeDocument/2006/relationships" xmlns:p="http://schemas.openxmlformats.org/presentationml/2006/main">
+  <p:cSld>
+    <p:spTree>
+      <p:nvGrpSpPr>
+        <p:cNvPr id="1" name="">
+          <a:extLst>
+            <a:ext uri="{FF2B5EF4-FFF2-40B4-BE49-F238E27FC236}">
               <a16:creationId xmlns:a16="http://schemas.microsoft.com/office/drawing/2014/main" id="{A183267B-B82B-1EDC-363F-2C9961D70AB9}"/>
             </a:ext>
           </a:extLst>
@@ -1164,7 +1272,7 @@
           <a:p>
             <a:fld id="{D16833E0-5E66-4D1D-89F5-BD860FDD8F71}" type="slidenum">
               <a:rPr lang="en-MY" smtClean="0"/>
-              <a:t>8</a:t>
+              <a:t>9</a:t>
             </a:fld>
             <a:endParaRPr lang="en-MY"/>
           </a:p>
@@ -1183,7 +1291,7 @@
 </p:notes>
 </file>
 
-<file path=ppt/notesSlides/notesSlide8.xml><?xml version="1.0" encoding="utf-8"?>
+<file path=ppt/notesSlides/notesSlide9.xml><?xml version="1.0" encoding="utf-8"?>
 <p:notes xmlns:a="http://schemas.openxmlformats.org/drawingml/2006/main" xmlns:r="http://schemas.openxmlformats.org/officeDocument/2006/relationships" xmlns:p="http://schemas.openxmlformats.org/presentationml/2006/main">
   <p:cSld>
     <p:spTree>
@@ -1272,7 +1380,7 @@
           <a:p>
             <a:fld id="{D16833E0-5E66-4D1D-89F5-BD860FDD8F71}" type="slidenum">
               <a:rPr lang="en-MY" smtClean="0"/>
-              <a:t>9</a:t>
+              <a:t>10</a:t>
             </a:fld>
             <a:endParaRPr lang="en-MY"/>
           </a:p>
@@ -1282,114 +1390,6 @@
     <p:extLst>
       <p:ext uri="{BB962C8B-B14F-4D97-AF65-F5344CB8AC3E}">
         <p14:creationId xmlns:p14="http://schemas.microsoft.com/office/powerpoint/2010/main" val="127372749"/>
-      </p:ext>
-    </p:extLst>
-  </p:cSld>
-  <p:clrMapOvr>
-    <a:masterClrMapping/>
-  </p:clrMapOvr>
-</p:notes>
-</file>
-
-<file path=ppt/notesSlides/notesSlide9.xml><?xml version="1.0" encoding="utf-8"?>
-<p:notes xmlns:a="http://schemas.openxmlformats.org/drawingml/2006/main" xmlns:r="http://schemas.openxmlformats.org/officeDocument/2006/relationships" xmlns:p="http://schemas.openxmlformats.org/presentationml/2006/main">
-  <p:cSld>
-    <p:spTree>
-      <p:nvGrpSpPr>
-        <p:cNvPr id="1" name="">
-          <a:extLst>
-            <a:ext uri="{FF2B5EF4-FFF2-40B4-BE49-F238E27FC236}">
-              <a16:creationId xmlns:a16="http://schemas.microsoft.com/office/drawing/2014/main" id="{AA54A910-8722-BE0D-ECC6-AE331ECADDCC}"/>
-            </a:ext>
-          </a:extLst>
-        </p:cNvPr>
-        <p:cNvGrpSpPr/>
-        <p:nvPr/>
-      </p:nvGrpSpPr>
-      <p:grpSpPr>
-        <a:xfrm>
-          <a:off x="0" y="0"/>
-          <a:ext cx="0" cy="0"/>
-          <a:chOff x="0" y="0"/>
-          <a:chExt cx="0" cy="0"/>
-        </a:xfrm>
-      </p:grpSpPr>
-      <p:sp>
-        <p:nvSpPr>
-          <p:cNvPr id="2" name="Slide Image Placeholder 1">
-            <a:extLst>
-              <a:ext uri="{FF2B5EF4-FFF2-40B4-BE49-F238E27FC236}">
-                <a16:creationId xmlns:a16="http://schemas.microsoft.com/office/drawing/2014/main" id="{C9FF1B51-0D4E-F4D9-C462-F4905C8AAF9C}"/>
-              </a:ext>
-            </a:extLst>
-          </p:cNvPr>
-          <p:cNvSpPr>
-            <a:spLocks noGrp="1" noRot="1" noChangeAspect="1"/>
-          </p:cNvSpPr>
-          <p:nvPr>
-            <p:ph type="sldImg"/>
-          </p:nvPr>
-        </p:nvSpPr>
-        <p:spPr/>
-      </p:sp>
-      <p:sp>
-        <p:nvSpPr>
-          <p:cNvPr id="3" name="Notes Placeholder 2">
-            <a:extLst>
-              <a:ext uri="{FF2B5EF4-FFF2-40B4-BE49-F238E27FC236}">
-                <a16:creationId xmlns:a16="http://schemas.microsoft.com/office/drawing/2014/main" id="{C41BCF9F-3AF4-EF24-64C9-01366B660CC8}"/>
-              </a:ext>
-            </a:extLst>
-          </p:cNvPr>
-          <p:cNvSpPr>
-            <a:spLocks noGrp="1"/>
-          </p:cNvSpPr>
-          <p:nvPr>
-            <p:ph type="body" idx="1"/>
-          </p:nvPr>
-        </p:nvSpPr>
-        <p:spPr/>
-        <p:txBody>
-          <a:bodyPr/>
-          <a:lstStyle/>
-          <a:p>
-            <a:endParaRPr lang="en-MY" dirty="0"/>
-          </a:p>
-        </p:txBody>
-      </p:sp>
-      <p:sp>
-        <p:nvSpPr>
-          <p:cNvPr id="4" name="Slide Number Placeholder 3">
-            <a:extLst>
-              <a:ext uri="{FF2B5EF4-FFF2-40B4-BE49-F238E27FC236}">
-                <a16:creationId xmlns:a16="http://schemas.microsoft.com/office/drawing/2014/main" id="{7A6CF6CA-73F6-4CE7-341F-2286B37A0478}"/>
-              </a:ext>
-            </a:extLst>
-          </p:cNvPr>
-          <p:cNvSpPr>
-            <a:spLocks noGrp="1"/>
-          </p:cNvSpPr>
-          <p:nvPr>
-            <p:ph type="sldNum" sz="quarter" idx="5"/>
-          </p:nvPr>
-        </p:nvSpPr>
-        <p:spPr/>
-        <p:txBody>
-          <a:bodyPr/>
-          <a:lstStyle/>
-          <a:p>
-            <a:fld id="{D16833E0-5E66-4D1D-89F5-BD860FDD8F71}" type="slidenum">
-              <a:rPr lang="en-MY" smtClean="0"/>
-              <a:t>10</a:t>
-            </a:fld>
-            <a:endParaRPr lang="en-MY"/>
-          </a:p>
-        </p:txBody>
-      </p:sp>
-    </p:spTree>
-    <p:extLst>
-      <p:ext uri="{BB962C8B-B14F-4D97-AF65-F5344CB8AC3E}">
-        <p14:creationId xmlns:p14="http://schemas.microsoft.com/office/powerpoint/2010/main" val="4002248972"/>
       </p:ext>
     </p:extLst>
   </p:cSld>
@@ -1570,7 +1570,7 @@
           <a:p>
             <a:fld id="{1CD01395-AC05-405C-BAB9-E5D2B9FDBB40}" type="datetimeFigureOut">
               <a:rPr lang="en-MY" smtClean="0"/>
-              <a:t>19/6/2026</a:t>
+              <a:t>22/6/2026</a:t>
             </a:fld>
             <a:endParaRPr lang="en-MY"/>
           </a:p>
@@ -1885,7 +1885,7 @@
           <a:p>
             <a:fld id="{1CD01395-AC05-405C-BAB9-E5D2B9FDBB40}" type="datetimeFigureOut">
               <a:rPr lang="en-MY" smtClean="0"/>
-              <a:t>19/6/2026</a:t>
+              <a:t>22/6/2026</a:t>
             </a:fld>
             <a:endParaRPr lang="en-MY"/>
           </a:p>
@@ -2107,7 +2107,7 @@
           <a:p>
             <a:fld id="{1CD01395-AC05-405C-BAB9-E5D2B9FDBB40}" type="datetimeFigureOut">
               <a:rPr lang="en-MY" smtClean="0"/>
-              <a:t>19/6/2026</a:t>
+              <a:t>22/6/2026</a:t>
             </a:fld>
             <a:endParaRPr lang="en-MY"/>
           </a:p>
@@ -2398,7 +2398,7 @@
           <a:p>
             <a:fld id="{1CD01395-AC05-405C-BAB9-E5D2B9FDBB40}" type="datetimeFigureOut">
               <a:rPr lang="en-MY" smtClean="0"/>
-              <a:t>19/6/2026</a:t>
+              <a:t>22/6/2026</a:t>
             </a:fld>
             <a:endParaRPr lang="en-MY"/>
           </a:p>
@@ -2852,7 +2852,7 @@
           <a:p>
             <a:fld id="{1CD01395-AC05-405C-BAB9-E5D2B9FDBB40}" type="datetimeFigureOut">
               <a:rPr lang="en-MY" smtClean="0"/>
-              <a:t>19/6/2026</a:t>
+              <a:t>22/6/2026</a:t>
             </a:fld>
             <a:endParaRPr lang="en-MY"/>
           </a:p>
@@ -3428,7 +3428,7 @@
           <a:p>
             <a:fld id="{1CD01395-AC05-405C-BAB9-E5D2B9FDBB40}" type="datetimeFigureOut">
               <a:rPr lang="en-MY" smtClean="0"/>
-              <a:t>19/6/2026</a:t>
+              <a:t>22/6/2026</a:t>
             </a:fld>
             <a:endParaRPr lang="en-MY"/>
           </a:p>
@@ -4289,7 +4289,7 @@
           <a:p>
             <a:fld id="{1CD01395-AC05-405C-BAB9-E5D2B9FDBB40}" type="datetimeFigureOut">
               <a:rPr lang="en-MY" smtClean="0"/>
-              <a:t>19/6/2026</a:t>
+              <a:t>22/6/2026</a:t>
             </a:fld>
             <a:endParaRPr lang="en-MY"/>
           </a:p>
@@ -4494,7 +4494,7 @@
           <a:p>
             <a:fld id="{1CD01395-AC05-405C-BAB9-E5D2B9FDBB40}" type="datetimeFigureOut">
               <a:rPr lang="en-MY" smtClean="0"/>
-              <a:t>19/6/2026</a:t>
+              <a:t>22/6/2026</a:t>
             </a:fld>
             <a:endParaRPr lang="en-MY"/>
           </a:p>
@@ -4708,7 +4708,7 @@
           <a:p>
             <a:fld id="{1CD01395-AC05-405C-BAB9-E5D2B9FDBB40}" type="datetimeFigureOut">
               <a:rPr lang="en-MY" smtClean="0"/>
-              <a:t>19/6/2026</a:t>
+              <a:t>22/6/2026</a:t>
             </a:fld>
             <a:endParaRPr lang="en-MY"/>
           </a:p>
@@ -4913,7 +4913,7 @@
           <a:p>
             <a:fld id="{1CD01395-AC05-405C-BAB9-E5D2B9FDBB40}" type="datetimeFigureOut">
               <a:rPr lang="en-MY" smtClean="0"/>
-              <a:t>19/6/2026</a:t>
+              <a:t>22/6/2026</a:t>
             </a:fld>
             <a:endParaRPr lang="en-MY"/>
           </a:p>
@@ -5193,7 +5193,7 @@
           <a:p>
             <a:fld id="{1CD01395-AC05-405C-BAB9-E5D2B9FDBB40}" type="datetimeFigureOut">
               <a:rPr lang="en-MY" smtClean="0"/>
-              <a:t>19/6/2026</a:t>
+              <a:t>22/6/2026</a:t>
             </a:fld>
             <a:endParaRPr lang="en-MY"/>
           </a:p>
@@ -5460,7 +5460,7 @@
           <a:p>
             <a:fld id="{1CD01395-AC05-405C-BAB9-E5D2B9FDBB40}" type="datetimeFigureOut">
               <a:rPr lang="en-MY" smtClean="0"/>
-              <a:t>19/6/2026</a:t>
+              <a:t>22/6/2026</a:t>
             </a:fld>
             <a:endParaRPr lang="en-MY"/>
           </a:p>
@@ -5875,7 +5875,7 @@
           <a:p>
             <a:fld id="{1CD01395-AC05-405C-BAB9-E5D2B9FDBB40}" type="datetimeFigureOut">
               <a:rPr lang="en-MY" smtClean="0"/>
-              <a:t>19/6/2026</a:t>
+              <a:t>22/6/2026</a:t>
             </a:fld>
             <a:endParaRPr lang="en-MY"/>
           </a:p>
@@ -6023,7 +6023,7 @@
           <a:p>
             <a:fld id="{1CD01395-AC05-405C-BAB9-E5D2B9FDBB40}" type="datetimeFigureOut">
               <a:rPr lang="en-MY" smtClean="0"/>
-              <a:t>19/6/2026</a:t>
+              <a:t>22/6/2026</a:t>
             </a:fld>
             <a:endParaRPr lang="en-MY"/>
           </a:p>
@@ -6148,7 +6148,7 @@
           <a:p>
             <a:fld id="{1CD01395-AC05-405C-BAB9-E5D2B9FDBB40}" type="datetimeFigureOut">
               <a:rPr lang="en-MY" smtClean="0"/>
-              <a:t>19/6/2026</a:t>
+              <a:t>22/6/2026</a:t>
             </a:fld>
             <a:endParaRPr lang="en-MY"/>
           </a:p>
@@ -6427,7 +6427,7 @@
           <a:p>
             <a:fld id="{1CD01395-AC05-405C-BAB9-E5D2B9FDBB40}" type="datetimeFigureOut">
               <a:rPr lang="en-MY" smtClean="0"/>
-              <a:t>19/6/2026</a:t>
+              <a:t>22/6/2026</a:t>
             </a:fld>
             <a:endParaRPr lang="en-MY"/>
           </a:p>
@@ -6742,7 +6742,7 @@
           <a:p>
             <a:fld id="{1CD01395-AC05-405C-BAB9-E5D2B9FDBB40}" type="datetimeFigureOut">
               <a:rPr lang="en-MY" smtClean="0"/>
-              <a:t>19/6/2026</a:t>
+              <a:t>22/6/2026</a:t>
             </a:fld>
             <a:endParaRPr lang="en-MY"/>
           </a:p>
@@ -6995,7 +6995,7 @@
           <a:p>
             <a:fld id="{1CD01395-AC05-405C-BAB9-E5D2B9FDBB40}" type="datetimeFigureOut">
               <a:rPr lang="en-MY" smtClean="0"/>
-              <a:t>19/6/2026</a:t>
+              <a:t>22/6/2026</a:t>
             </a:fld>
             <a:endParaRPr lang="en-MY"/>
           </a:p>
@@ -7522,7 +7522,7 @@
     <p:bg>
       <p:bgPr>
         <a:solidFill>
-          <a:schemeClr val="bg1"/>
+          <a:srgbClr val="CDF6F9"/>
         </a:solidFill>
         <a:effectLst/>
       </p:bgPr>
@@ -7532,7 +7532,7 @@
         <p:cNvPr id="1" name="">
           <a:extLst>
             <a:ext uri="{FF2B5EF4-FFF2-40B4-BE49-F238E27FC236}">
-              <a16:creationId xmlns:a16="http://schemas.microsoft.com/office/drawing/2014/main" id="{F0F2548E-9A0F-EFA7-4A68-4D96B0D0C79A}"/>
+              <a16:creationId xmlns:a16="http://schemas.microsoft.com/office/drawing/2014/main" id="{700F46A2-011D-3546-0B8A-E87BD8F1A4B0}"/>
             </a:ext>
           </a:extLst>
         </p:cNvPr>
@@ -7547,12 +7547,55 @@
           <a:chExt cx="0" cy="0"/>
         </a:xfrm>
       </p:grpSpPr>
+      <p:sp>
+        <p:nvSpPr>
+          <p:cNvPr id="2" name="TextBox 1">
+            <a:extLst>
+              <a:ext uri="{FF2B5EF4-FFF2-40B4-BE49-F238E27FC236}">
+                <a16:creationId xmlns:a16="http://schemas.microsoft.com/office/drawing/2014/main" id="{D2532F23-4670-2ED4-3919-B3B8454E3933}"/>
+              </a:ext>
+            </a:extLst>
+          </p:cNvPr>
+          <p:cNvSpPr txBox="1"/>
+          <p:nvPr/>
+        </p:nvSpPr>
+        <p:spPr>
+          <a:xfrm>
+            <a:off x="1063259" y="2767280"/>
+            <a:ext cx="4852419" cy="1323439"/>
+          </a:xfrm>
+          <a:prstGeom prst="rect">
+            <a:avLst/>
+          </a:prstGeom>
+          <a:noFill/>
+        </p:spPr>
+        <p:txBody>
+          <a:bodyPr wrap="none" rtlCol="0">
+            <a:spAutoFit/>
+          </a:bodyPr>
+          <a:lstStyle/>
+          <a:p>
+            <a:r>
+              <a:rPr lang="en-US" sz="4000" dirty="0" err="1"/>
+              <a:t>DeviceIdentifierLibrary</a:t>
+            </a:r>
+            <a:endParaRPr lang="en-US" sz="4000" dirty="0"/>
+          </a:p>
+          <a:p>
+            <a:pPr algn="ctr"/>
+            <a:r>
+              <a:rPr lang="en-US" sz="4000" dirty="0"/>
+              <a:t>workflow</a:t>
+            </a:r>
+          </a:p>
+        </p:txBody>
+      </p:sp>
       <p:pic>
         <p:nvPicPr>
-          <p:cNvPr id="5" name="Picture 4">
+          <p:cNvPr id="4" name="Picture 3">
             <a:extLst>
               <a:ext uri="{FF2B5EF4-FFF2-40B4-BE49-F238E27FC236}">
-                <a16:creationId xmlns:a16="http://schemas.microsoft.com/office/drawing/2014/main" id="{4993614A-CAD1-31A5-3EFA-9390AA2C9D9F}"/>
+                <a16:creationId xmlns:a16="http://schemas.microsoft.com/office/drawing/2014/main" id="{590A2A64-8894-0919-1FE3-D9F8E44114DA}"/>
               </a:ext>
             </a:extLst>
           </p:cNvPr>
@@ -7562,15 +7605,21 @@
           <p:nvPr/>
         </p:nvPicPr>
         <p:blipFill>
-          <a:blip r:embed="rId3"/>
+          <a:blip r:embed="rId3">
+            <a:extLst>
+              <a:ext uri="{28A0092B-C50C-407E-A947-70E740481C1C}">
+                <a14:useLocalDpi xmlns:a14="http://schemas.microsoft.com/office/drawing/2010/main" val="0"/>
+              </a:ext>
+            </a:extLst>
+          </a:blip>
           <a:stretch>
             <a:fillRect/>
           </a:stretch>
         </p:blipFill>
         <p:spPr>
           <a:xfrm>
-            <a:off x="4327523" y="137160"/>
-            <a:ext cx="3536954" cy="6331890"/>
+            <a:off x="7099284" y="230886"/>
+            <a:ext cx="4264152" cy="6396228"/>
           </a:xfrm>
           <a:prstGeom prst="rect">
             <a:avLst/>
@@ -7580,7 +7629,7 @@
     </p:spTree>
     <p:extLst>
       <p:ext uri="{BB962C8B-B14F-4D97-AF65-F5344CB8AC3E}">
-        <p14:creationId xmlns:p14="http://schemas.microsoft.com/office/powerpoint/2010/main" val="3829516895"/>
+        <p14:creationId xmlns:p14="http://schemas.microsoft.com/office/powerpoint/2010/main" val="975718132"/>
       </p:ext>
     </p:extLst>
   </p:cSld>
@@ -13466,14 +13515,64 @@
         </p:blipFill>
         <p:spPr>
           <a:xfrm>
-            <a:off x="2990088" y="703237"/>
-            <a:ext cx="5577840" cy="4787717"/>
+            <a:off x="5373551" y="817962"/>
+            <a:ext cx="6083881" cy="5222075"/>
           </a:xfrm>
           <a:prstGeom prst="rect">
             <a:avLst/>
           </a:prstGeom>
         </p:spPr>
       </p:pic>
+      <p:sp>
+        <p:nvSpPr>
+          <p:cNvPr id="3" name="TextBox 2">
+            <a:extLst>
+              <a:ext uri="{FF2B5EF4-FFF2-40B4-BE49-F238E27FC236}">
+                <a16:creationId xmlns:a16="http://schemas.microsoft.com/office/drawing/2014/main" id="{E79CD4A6-8A4A-78B4-07C1-7E0686FA18EC}"/>
+              </a:ext>
+            </a:extLst>
+          </p:cNvPr>
+          <p:cNvSpPr txBox="1"/>
+          <p:nvPr/>
+        </p:nvSpPr>
+        <p:spPr>
+          <a:xfrm>
+            <a:off x="734568" y="2282648"/>
+            <a:ext cx="4237378" cy="1938992"/>
+          </a:xfrm>
+          <a:prstGeom prst="rect">
+            <a:avLst/>
+          </a:prstGeom>
+          <a:noFill/>
+        </p:spPr>
+        <p:txBody>
+          <a:bodyPr wrap="none" rtlCol="0">
+            <a:spAutoFit/>
+          </a:bodyPr>
+          <a:lstStyle/>
+          <a:p>
+            <a:pPr algn="ctr"/>
+            <a:r>
+              <a:rPr lang="en-US" sz="4000" dirty="0"/>
+              <a:t>manual assign </a:t>
+            </a:r>
+          </a:p>
+          <a:p>
+            <a:pPr algn="ctr"/>
+            <a:r>
+              <a:rPr lang="en-US" sz="4000" dirty="0"/>
+              <a:t>type, section, cluster</a:t>
+            </a:r>
+          </a:p>
+          <a:p>
+            <a:pPr algn="ctr"/>
+            <a:r>
+              <a:rPr lang="en-US" sz="4000" dirty="0"/>
+              <a:t>workflow</a:t>
+            </a:r>
+          </a:p>
+        </p:txBody>
+      </p:sp>
     </p:spTree>
     <p:extLst>
       <p:ext uri="{BB962C8B-B14F-4D97-AF65-F5344CB8AC3E}">
@@ -13488,6 +13587,130 @@
 </file>
 
 <file path=ppt/slides/slide8.xml><?xml version="1.0" encoding="utf-8"?>
+<p:sld xmlns:a="http://schemas.openxmlformats.org/drawingml/2006/main" xmlns:r="http://schemas.openxmlformats.org/officeDocument/2006/relationships" xmlns:p="http://schemas.openxmlformats.org/presentationml/2006/main" showMasterSp="0">
+  <p:cSld>
+    <p:bg>
+      <p:bgPr>
+        <a:solidFill>
+          <a:schemeClr val="bg1"/>
+        </a:solidFill>
+        <a:effectLst/>
+      </p:bgPr>
+    </p:bg>
+    <p:spTree>
+      <p:nvGrpSpPr>
+        <p:cNvPr id="1" name="">
+          <a:extLst>
+            <a:ext uri="{FF2B5EF4-FFF2-40B4-BE49-F238E27FC236}">
+              <a16:creationId xmlns:a16="http://schemas.microsoft.com/office/drawing/2014/main" id="{F0F2548E-9A0F-EFA7-4A68-4D96B0D0C79A}"/>
+            </a:ext>
+          </a:extLst>
+        </p:cNvPr>
+        <p:cNvGrpSpPr/>
+        <p:nvPr/>
+      </p:nvGrpSpPr>
+      <p:grpSpPr>
+        <a:xfrm>
+          <a:off x="0" y="0"/>
+          <a:ext cx="0" cy="0"/>
+          <a:chOff x="0" y="0"/>
+          <a:chExt cx="0" cy="0"/>
+        </a:xfrm>
+      </p:grpSpPr>
+      <p:pic>
+        <p:nvPicPr>
+          <p:cNvPr id="5" name="Picture 4">
+            <a:extLst>
+              <a:ext uri="{FF2B5EF4-FFF2-40B4-BE49-F238E27FC236}">
+                <a16:creationId xmlns:a16="http://schemas.microsoft.com/office/drawing/2014/main" id="{4993614A-CAD1-31A5-3EFA-9390AA2C9D9F}"/>
+              </a:ext>
+            </a:extLst>
+          </p:cNvPr>
+          <p:cNvPicPr>
+            <a:picLocks noChangeAspect="1"/>
+          </p:cNvPicPr>
+          <p:nvPr/>
+        </p:nvPicPr>
+        <p:blipFill>
+          <a:blip r:embed="rId3"/>
+          <a:stretch>
+            <a:fillRect/>
+          </a:stretch>
+        </p:blipFill>
+        <p:spPr>
+          <a:xfrm>
+            <a:off x="7975979" y="155448"/>
+            <a:ext cx="3536954" cy="6331890"/>
+          </a:xfrm>
+          <a:prstGeom prst="rect">
+            <a:avLst/>
+          </a:prstGeom>
+        </p:spPr>
+      </p:pic>
+      <p:sp>
+        <p:nvSpPr>
+          <p:cNvPr id="3" name="TextBox 2">
+            <a:extLst>
+              <a:ext uri="{FF2B5EF4-FFF2-40B4-BE49-F238E27FC236}">
+                <a16:creationId xmlns:a16="http://schemas.microsoft.com/office/drawing/2014/main" id="{B79596CD-7BBB-CEC9-93CC-478D5B0263B2}"/>
+              </a:ext>
+            </a:extLst>
+          </p:cNvPr>
+          <p:cNvSpPr txBox="1"/>
+          <p:nvPr/>
+        </p:nvSpPr>
+        <p:spPr>
+          <a:xfrm>
+            <a:off x="2645664" y="2246072"/>
+            <a:ext cx="4237378" cy="1938992"/>
+          </a:xfrm>
+          <a:prstGeom prst="rect">
+            <a:avLst/>
+          </a:prstGeom>
+          <a:noFill/>
+        </p:spPr>
+        <p:txBody>
+          <a:bodyPr wrap="none" rtlCol="0">
+            <a:spAutoFit/>
+          </a:bodyPr>
+          <a:lstStyle/>
+          <a:p>
+            <a:pPr algn="ctr"/>
+            <a:r>
+              <a:rPr lang="en-US" sz="4000" dirty="0"/>
+              <a:t>manual assign </a:t>
+            </a:r>
+          </a:p>
+          <a:p>
+            <a:pPr algn="ctr"/>
+            <a:r>
+              <a:rPr lang="en-US" sz="4000" dirty="0"/>
+              <a:t>type, section, cluster</a:t>
+            </a:r>
+          </a:p>
+          <a:p>
+            <a:pPr algn="ctr"/>
+            <a:r>
+              <a:rPr lang="en-US" sz="4000" dirty="0"/>
+              <a:t>workflow</a:t>
+            </a:r>
+          </a:p>
+        </p:txBody>
+      </p:sp>
+    </p:spTree>
+    <p:extLst>
+      <p:ext uri="{BB962C8B-B14F-4D97-AF65-F5344CB8AC3E}">
+        <p14:creationId xmlns:p14="http://schemas.microsoft.com/office/powerpoint/2010/main" val="3829516895"/>
+      </p:ext>
+    </p:extLst>
+  </p:cSld>
+  <p:clrMapOvr>
+    <a:masterClrMapping/>
+  </p:clrMapOvr>
+</p:sld>
+</file>
+
+<file path=ppt/slides/slide9.xml><?xml version="1.0" encoding="utf-8"?>
 <p:sld xmlns:a="http://schemas.openxmlformats.org/drawingml/2006/main" xmlns:r="http://schemas.openxmlformats.org/officeDocument/2006/relationships" xmlns:p="http://schemas.openxmlformats.org/presentationml/2006/main" showMasterSp="0">
   <p:cSld>
     <p:bg>
@@ -13613,121 +13836,6 @@
     <p:extLst>
       <p:ext uri="{BB962C8B-B14F-4D97-AF65-F5344CB8AC3E}">
         <p14:creationId xmlns:p14="http://schemas.microsoft.com/office/powerpoint/2010/main" val="16583078"/>
-      </p:ext>
-    </p:extLst>
-  </p:cSld>
-  <p:clrMapOvr>
-    <a:masterClrMapping/>
-  </p:clrMapOvr>
-</p:sld>
-</file>
-
-<file path=ppt/slides/slide9.xml><?xml version="1.0" encoding="utf-8"?>
-<p:sld xmlns:a="http://schemas.openxmlformats.org/drawingml/2006/main" xmlns:r="http://schemas.openxmlformats.org/officeDocument/2006/relationships" xmlns:p="http://schemas.openxmlformats.org/presentationml/2006/main" showMasterSp="0">
-  <p:cSld>
-    <p:bg>
-      <p:bgPr>
-        <a:solidFill>
-          <a:srgbClr val="CDF6F9"/>
-        </a:solidFill>
-        <a:effectLst/>
-      </p:bgPr>
-    </p:bg>
-    <p:spTree>
-      <p:nvGrpSpPr>
-        <p:cNvPr id="1" name="">
-          <a:extLst>
-            <a:ext uri="{FF2B5EF4-FFF2-40B4-BE49-F238E27FC236}">
-              <a16:creationId xmlns:a16="http://schemas.microsoft.com/office/drawing/2014/main" id="{700F46A2-011D-3546-0B8A-E87BD8F1A4B0}"/>
-            </a:ext>
-          </a:extLst>
-        </p:cNvPr>
-        <p:cNvGrpSpPr/>
-        <p:nvPr/>
-      </p:nvGrpSpPr>
-      <p:grpSpPr>
-        <a:xfrm>
-          <a:off x="0" y="0"/>
-          <a:ext cx="0" cy="0"/>
-          <a:chOff x="0" y="0"/>
-          <a:chExt cx="0" cy="0"/>
-        </a:xfrm>
-      </p:grpSpPr>
-      <p:sp>
-        <p:nvSpPr>
-          <p:cNvPr id="2" name="TextBox 1">
-            <a:extLst>
-              <a:ext uri="{FF2B5EF4-FFF2-40B4-BE49-F238E27FC236}">
-                <a16:creationId xmlns:a16="http://schemas.microsoft.com/office/drawing/2014/main" id="{D2532F23-4670-2ED4-3919-B3B8454E3933}"/>
-              </a:ext>
-            </a:extLst>
-          </p:cNvPr>
-          <p:cNvSpPr txBox="1"/>
-          <p:nvPr/>
-        </p:nvSpPr>
-        <p:spPr>
-          <a:xfrm>
-            <a:off x="6845315" y="768096"/>
-            <a:ext cx="3036793" cy="369332"/>
-          </a:xfrm>
-          <a:prstGeom prst="rect">
-            <a:avLst/>
-          </a:prstGeom>
-          <a:noFill/>
-        </p:spPr>
-        <p:txBody>
-          <a:bodyPr wrap="none" rtlCol="0">
-            <a:spAutoFit/>
-          </a:bodyPr>
-          <a:lstStyle/>
-          <a:p>
-            <a:r>
-              <a:rPr lang="en-US" dirty="0"/>
-              <a:t>HOW TO SORT THE PROJECT?</a:t>
-            </a:r>
-          </a:p>
-        </p:txBody>
-      </p:sp>
-      <p:pic>
-        <p:nvPicPr>
-          <p:cNvPr id="4" name="Picture 3">
-            <a:extLst>
-              <a:ext uri="{FF2B5EF4-FFF2-40B4-BE49-F238E27FC236}">
-                <a16:creationId xmlns:a16="http://schemas.microsoft.com/office/drawing/2014/main" id="{590A2A64-8894-0919-1FE3-D9F8E44114DA}"/>
-              </a:ext>
-            </a:extLst>
-          </p:cNvPr>
-          <p:cNvPicPr>
-            <a:picLocks noChangeAspect="1"/>
-          </p:cNvPicPr>
-          <p:nvPr/>
-        </p:nvPicPr>
-        <p:blipFill>
-          <a:blip r:embed="rId3">
-            <a:extLst>
-              <a:ext uri="{28A0092B-C50C-407E-A947-70E740481C1C}">
-                <a14:useLocalDpi xmlns:a14="http://schemas.microsoft.com/office/drawing/2010/main" val="0"/>
-              </a:ext>
-            </a:extLst>
-          </a:blip>
-          <a:stretch>
-            <a:fillRect/>
-          </a:stretch>
-        </p:blipFill>
-        <p:spPr>
-          <a:xfrm>
-            <a:off x="240299" y="230886"/>
-            <a:ext cx="4264152" cy="6396228"/>
-          </a:xfrm>
-          <a:prstGeom prst="rect">
-            <a:avLst/>
-          </a:prstGeom>
-        </p:spPr>
-      </p:pic>
-    </p:spTree>
-    <p:extLst>
-      <p:ext uri="{BB962C8B-B14F-4D97-AF65-F5344CB8AC3E}">
-        <p14:creationId xmlns:p14="http://schemas.microsoft.com/office/powerpoint/2010/main" val="975718132"/>
       </p:ext>
     </p:extLst>
   </p:cSld>

</xml_diff>